<commit_message>
Update slide deck to match the published PDF; ignore Office lock files
Co-Authored-By: Claude Opus 4.8 <noreply@anthropic.com>
</commit_message>
<xml_diff>
--- a/slides/Cotiviti-Topic2.pptx
+++ b/slides/Cotiviti-Topic2.pptx
@@ -115,267 +115,6 @@
     </a:lvl9pPr>
   </p:defaultTextStyle>
 </p:presentation>
-</file>
-
-<file path=ppt/charts/chart1.xml><?xml version="1.0" encoding="utf-8"?>
-<c:chartSpace xmlns:c="http://schemas.openxmlformats.org/drawingml/2006/chart" xmlns:a="http://schemas.openxmlformats.org/drawingml/2006/main" xmlns:r="http://schemas.openxmlformats.org/officeDocument/2006/relationships">
-  <c:date1904 val="0"/>
-  <c:roundedCorners val="1"/>
-  <c:chart>
-    <c:autoTitleDeleted val="1"/>
-    <c:plotArea>
-      <c:layout/>
-      <c:barChart>
-        <c:barDir val="col"/>
-        <c:grouping val="clustered"/>
-        <c:varyColors val="0"/>
-        <c:ser>
-          <c:idx val="0"/>
-          <c:order val="0"/>
-          <c:tx>
-            <c:strRef>
-              <c:f>Sheet1!$B$1</c:f>
-              <c:strCache>
-                <c:ptCount val="1"/>
-                <c:pt idx="0">
-                  <c:v>claims</c:v>
-                </c:pt>
-              </c:strCache>
-            </c:strRef>
-          </c:tx>
-          <c:spPr>
-            <a:solidFill>
-              <a:srgbClr val="0E7C7B"/>
-            </a:solidFill>
-            <a:effectLst/>
-          </c:spPr>
-          <c:invertIfNegative val="0"/>
-          <c:dLbls>
-            <c:numFmt formatCode="#,##0" sourceLinked="0"/>
-            <c:txPr>
-              <a:bodyPr/>
-              <a:lstStyle/>
-              <a:p>
-                <a:pPr>
-                  <a:defRPr b="0" i="0" strike="noStrike" sz="1200" u="none">
-                    <a:solidFill>
-                      <a:srgbClr val="000000"/>
-                    </a:solidFill>
-                    <a:latin typeface="Arial"/>
-                  </a:defRPr>
-                </a:pPr>
-              </a:p>
-            </c:txPr>
-            <c:showLegendKey val="0"/>
-            <c:showVal val="0"/>
-            <c:showCatName val="0"/>
-            <c:showSerName val="0"/>
-            <c:showPercent val="0"/>
-            <c:showBubbleSize val="0"/>
-            <c:showLeaderLines val="0"/>
-          </c:dLbls>
-          <c:cat>
-            <c:multiLvlStrRef>
-              <c:f>Sheet1!$A$2:$A$9</c:f>
-              <c:multiLvlStrCache>
-                <c:ptCount val="8"/>
-                <c:lvl>
-                  <c:pt idx="0">
-                    <c:v>$27k</c:v>
-                  </c:pt>
-                  <c:pt idx="1">
-                    <c:v>$28k</c:v>
-                  </c:pt>
-                  <c:pt idx="2">
-                    <c:v>$30k</c:v>
-                  </c:pt>
-                  <c:pt idx="3">
-                    <c:v>$31k</c:v>
-                  </c:pt>
-                  <c:pt idx="4">
-                    <c:v>$32k</c:v>
-                  </c:pt>
-                  <c:pt idx="5">
-                    <c:v>$34k</c:v>
-                  </c:pt>
-                  <c:pt idx="6">
-                    <c:v>$35k</c:v>
-                  </c:pt>
-                  <c:pt idx="7">
-                    <c:v>$37k</c:v>
-                  </c:pt>
-                </c:lvl>
-              </c:multiLvlStrCache>
-            </c:multiLvlStrRef>
-          </c:cat>
-          <c:val>
-            <c:numRef>
-              <c:f>Sheet1!$B$2:$B$9</c:f>
-              <c:numCache>
-                <c:formatCode>General</c:formatCode>
-                <c:ptCount val="8"/>
-                <c:pt idx="0">
-                  <c:v>1</c:v>
-                </c:pt>
-                <c:pt idx="1">
-                  <c:v>5</c:v>
-                </c:pt>
-                <c:pt idx="2">
-                  <c:v>4</c:v>
-                </c:pt>
-                <c:pt idx="3">
-                  <c:v>6</c:v>
-                </c:pt>
-                <c:pt idx="4">
-                  <c:v>2</c:v>
-                </c:pt>
-                <c:pt idx="5">
-                  <c:v>4</c:v>
-                </c:pt>
-                <c:pt idx="6">
-                  <c:v>0</c:v>
-                </c:pt>
-                <c:pt idx="7">
-                  <c:v>2</c:v>
-                </c:pt>
-              </c:numCache>
-            </c:numRef>
-          </c:val>
-        </c:ser>
-        <c:dLbls>
-          <c:numFmt formatCode="#,##0" sourceLinked="0"/>
-          <c:txPr>
-            <a:bodyPr/>
-            <a:lstStyle/>
-            <a:p>
-              <a:pPr>
-                <a:defRPr b="0" i="0" strike="noStrike" sz="1200" u="none">
-                  <a:solidFill>
-                    <a:srgbClr val="000000"/>
-                  </a:solidFill>
-                  <a:latin typeface="Arial"/>
-                </a:defRPr>
-              </a:pPr>
-            </a:p>
-          </c:txPr>
-          <c:showLegendKey val="0"/>
-          <c:showVal val="0"/>
-          <c:showCatName val="0"/>
-          <c:showSerName val="0"/>
-          <c:showPercent val="0"/>
-          <c:showBubbleSize val="0"/>
-          <c:showLeaderLines val="0"/>
-        </c:dLbls>
-        <c:gapWidth val="40"/>
-        <c:overlap val="0"/>
-        <c:axId val="2094734554"/>
-        <c:axId val="2094734552"/>
-        <c:axId val="2094734556"/>
-      </c:barChart>
-      <c:catAx>
-        <c:axId val="2094734554"/>
-        <c:scaling>
-          <c:orientation val="minMax"/>
-        </c:scaling>
-        <c:delete val="0"/>
-        <c:axPos val="b"/>
-        <c:numFmt formatCode="General" sourceLinked="1"/>
-        <c:majorTickMark val="out"/>
-        <c:minorTickMark val="none"/>
-        <c:tickLblPos val="low"/>
-        <c:spPr>
-          <a:ln w="12700" cap="flat">
-            <a:solidFill>
-              <a:srgbClr val="888888"/>
-            </a:solidFill>
-            <a:prstDash val="solid"/>
-            <a:round/>
-          </a:ln>
-        </c:spPr>
-        <c:txPr>
-          <a:bodyPr/>
-          <a:lstStyle/>
-          <a:p>
-            <a:pPr>
-              <a:defRPr sz="800" b="0" i="0" u="none" strike="noStrike">
-                <a:solidFill>
-                  <a:srgbClr val="64748B"/>
-                </a:solidFill>
-                <a:latin typeface="Arial"/>
-              </a:defRPr>
-            </a:pPr>
-            <a:endParaRPr lang="en-US"/>
-          </a:p>
-        </c:txPr>
-        <c:crossAx val="2094734552"/>
-        <c:crosses val="autoZero"/>
-        <c:auto val="1"/>
-        <c:lblAlgn val="ctr"/>
-        <c:noMultiLvlLbl val="1"/>
-      </c:catAx>
-      <c:valAx>
-        <c:axId val="2094734552"/>
-        <c:scaling>
-          <c:orientation val="minMax"/>
-        </c:scaling>
-        <c:delete val="1"/>
-        <c:axPos val="l"/>
-        <c:numFmt formatCode="General" sourceLinked="0"/>
-        <c:majorTickMark val="out"/>
-        <c:minorTickMark val="none"/>
-        <c:tickLblPos val="nextTo"/>
-        <c:spPr>
-          <a:ln w="12700" cap="flat">
-            <a:solidFill>
-              <a:srgbClr val="888888"/>
-            </a:solidFill>
-            <a:prstDash val="solid"/>
-            <a:round/>
-          </a:ln>
-        </c:spPr>
-        <c:txPr>
-          <a:bodyPr/>
-          <a:lstStyle/>
-          <a:p>
-            <a:pPr>
-              <a:defRPr sz="1200" b="0" i="0" u="none" strike="noStrike">
-                <a:solidFill>
-                  <a:srgbClr val="000000"/>
-                </a:solidFill>
-                <a:latin typeface="Arial"/>
-              </a:defRPr>
-            </a:pPr>
-            <a:endParaRPr lang="en-US"/>
-          </a:p>
-        </c:txPr>
-        <c:crossAx val="2094734554"/>
-        <c:crosses val="autoZero"/>
-        <c:crossBetween val="between"/>
-      </c:valAx>
-      <c:spPr>
-        <a:noFill/>
-        <a:ln>
-          <a:noFill/>
-        </a:ln>
-        <a:effectLst/>
-      </c:spPr>
-    </c:plotArea>
-    <c:plotVisOnly val="1"/>
-    <c:dispBlanksAs val="span"/>
-  </c:chart>
-  <c:spPr>
-    <a:solidFill>
-      <a:srgbClr val="FFFFFF"/>
-    </a:solidFill>
-    <a:ln>
-      <a:noFill/>
-    </a:ln>
-    <a:effectLst/>
-  </c:spPr>
-  <c:externalData r:id="rId1">
-    <c:autoUpdate val="0"/>
-  </c:externalData>
-</c:chartSpace>
 </file>
 
 <file path=ppt/notesMasters/notesMaster1.xml><?xml version="1.0" encoding="utf-8"?>
@@ -4543,7 +4282,7 @@
                 <a:ea typeface="Calibri" pitchFamily="34" charset="-122"/>
                 <a:cs typeface="Calibri" pitchFamily="34" charset="-120"/>
               </a:rPr>
-              <a:t>Payment integrity is pattern recognition at national scale. A first pass that is faster, steadier, and able to explain itself turns a multi-billion-dollar error rate into something a team can actually work through. The open question was never whether AI can read a claim. It's whether it can be trusted to.</a:t>
+              <a:t>Payment integrity is pattern recognition at national scale. A first pass that is faster, steadier, and able to explain itself turns a multi-billion-dollar error rate into something a team can actually work through. That only works if reviewers trust the output, and trust comes from seeing how it got there.</a:t>
             </a:r>
             <a:endParaRPr lang="en-US" sz="1500" dirty="0"/>
           </a:p>
@@ -5841,8 +5580,8 @@
         </p:nvSpPr>
         <p:spPr>
           <a:xfrm>
-            <a:off x="7132320" y="3968496"/>
-            <a:ext cx="0" cy="-384048"/>
+            <a:off x="7132320" y="3584448"/>
+            <a:ext cx="0" cy="384048"/>
           </a:xfrm>
           <a:prstGeom prst="line">
             <a:avLst/>
@@ -5853,7 +5592,7 @@
               <a:srgbClr val="0E7C7B"/>
             </a:solidFill>
             <a:prstDash val="solid"/>
-            <a:tailEnd type="triangle"/>
+            <a:headEnd type="triangle"/>
           </a:ln>
         </p:spPr>
       </p:sp>
@@ -9438,11 +9177,11 @@
         <p:spPr>
           <a:xfrm>
             <a:off x="457200" y="1783080"/>
-            <a:ext cx="3611880" cy="2697480"/>
+            <a:ext cx="3611880" cy="3429000"/>
           </a:xfrm>
           <a:prstGeom prst="roundRect">
             <a:avLst>
-              <a:gd name="adj" fmla="val 2712"/>
+              <a:gd name="adj" fmla="val 2133"/>
             </a:avLst>
           </a:prstGeom>
           <a:solidFill>
@@ -9565,7 +9304,7 @@
         <p:spPr>
           <a:xfrm>
             <a:off x="731520" y="3310128"/>
-            <a:ext cx="3108960" cy="1097280"/>
+            <a:ext cx="3108960" cy="1234440"/>
           </a:xfrm>
           <a:prstGeom prst="rect">
             <a:avLst/>
@@ -9589,7 +9328,7 @@
                 <a:ea typeface="Calibri" pitchFamily="34" charset="-122"/>
                 <a:cs typeface="Calibri" pitchFamily="34" charset="-120"/>
               </a:rPr>
-              <a:t>Every tool call and its result is a recorded step. That chain of reasoning is the audit trail, the same record a regulator or an appealing provider would ask for.</a:t>
+              <a:t>The tool calls and their results are the reasoning, so the explanation comes for free. It's the record a regulator or an appealing provider would ask for.</a:t>
             </a:r>
             <a:endParaRPr lang="en-US" sz="1250" dirty="0"/>
           </a:p>
@@ -9603,12 +9342,74 @@
         </p:nvSpPr>
         <p:spPr>
           <a:xfrm>
+            <a:off x="731520" y="4608576"/>
+            <a:ext cx="3063240" cy="0"/>
+          </a:xfrm>
+          <a:prstGeom prst="line">
+            <a:avLst/>
+          </a:prstGeom>
+          <a:noFill/>
+          <a:ln w="12700">
+            <a:solidFill>
+              <a:srgbClr val="E2E8F0"/>
+            </a:solidFill>
+            <a:prstDash val="solid"/>
+          </a:ln>
+        </p:spPr>
+      </p:sp>
+      <p:sp>
+        <p:nvSpPr>
+          <p:cNvPr id="11" name="Text 9"/>
+          <p:cNvSpPr/>
+          <p:nvPr/>
+        </p:nvSpPr>
+        <p:spPr>
+          <a:xfrm>
+            <a:off x="731520" y="4700016"/>
+            <a:ext cx="3108960" cy="457200"/>
+          </a:xfrm>
+          <a:prstGeom prst="rect">
+            <a:avLst/>
+          </a:prstGeom>
+          <a:noFill/>
+          <a:ln/>
+        </p:spPr>
+        <p:txBody>
+          <a:bodyPr wrap="square" lIns="0" tIns="0" rIns="0" bIns="0" rtlCol="0" anchor="ctr"/>
+          <a:lstStyle/>
+          <a:p>
+            <a:pPr indent="0" marL="0">
+              <a:buNone/>
+            </a:pPr>
+            <a:r>
+              <a:rPr lang="en-US" sz="1150" i="1" dirty="0">
+                <a:solidFill>
+                  <a:srgbClr val="0B5E5D"/>
+                </a:solidFill>
+                <a:latin typeface="Calibri" pitchFamily="34" charset="0"/>
+                <a:ea typeface="Calibri" pitchFamily="34" charset="-122"/>
+                <a:cs typeface="Calibri" pitchFamily="34" charset="-120"/>
+              </a:rPr>
+              <a:t>In the demo: the audit trail listed under every claim.</a:t>
+            </a:r>
+            <a:endParaRPr lang="en-US" sz="1150" dirty="0"/>
+          </a:p>
+        </p:txBody>
+      </p:sp>
+      <p:sp>
+        <p:nvSpPr>
+          <p:cNvPr id="12" name="Shape 10"/>
+          <p:cNvSpPr/>
+          <p:nvPr/>
+        </p:nvSpPr>
+        <p:spPr>
+          <a:xfrm>
             <a:off x="4279392" y="1783080"/>
-            <a:ext cx="3611880" cy="2697480"/>
+            <a:ext cx="3611880" cy="3429000"/>
           </a:xfrm>
           <a:prstGeom prst="roundRect">
             <a:avLst>
-              <a:gd name="adj" fmla="val 2712"/>
+              <a:gd name="adj" fmla="val 2133"/>
             </a:avLst>
           </a:prstGeom>
           <a:solidFill>
@@ -9626,7 +9427,7 @@
       </p:sp>
       <p:sp>
         <p:nvSpPr>
-          <p:cNvPr id="11" name="Shape 9"/>
+          <p:cNvPr id="13" name="Shape 11"/>
           <p:cNvSpPr/>
           <p:nvPr/>
         </p:nvSpPr>
@@ -9646,7 +9447,7 @@
       </p:sp>
       <p:sp>
         <p:nvSpPr>
-          <p:cNvPr id="12" name="Text 10"/>
+          <p:cNvPr id="14" name="Text 12"/>
           <p:cNvSpPr/>
           <p:nvPr/>
         </p:nvSpPr>
@@ -9685,7 +9486,7 @@
       </p:sp>
       <p:sp>
         <p:nvSpPr>
-          <p:cNvPr id="13" name="Text 11"/>
+          <p:cNvPr id="15" name="Text 13"/>
           <p:cNvSpPr/>
           <p:nvPr/>
         </p:nvSpPr>
@@ -9724,14 +9525,14 @@
       </p:sp>
       <p:sp>
         <p:nvSpPr>
-          <p:cNvPr id="14" name="Text 12"/>
+          <p:cNvPr id="16" name="Text 14"/>
           <p:cNvSpPr/>
           <p:nvPr/>
         </p:nvSpPr>
         <p:spPr>
           <a:xfrm>
             <a:off x="4553712" y="3310128"/>
-            <a:ext cx="3108960" cy="1097280"/>
+            <a:ext cx="3108960" cy="1234440"/>
           </a:xfrm>
           <a:prstGeom prst="rect">
             <a:avLst/>
@@ -9755,7 +9556,7 @@
                 <a:ea typeface="Calibri" pitchFamily="34" charset="-122"/>
                 <a:cs typeface="Calibri" pitchFamily="34" charset="-120"/>
               </a:rPr>
-              <a:t>The fix for LLM overconfidence (Tian et al., 2025): calibrate confidence and route on it. Only high-confidence approvals auto-clear; everything else goes to a person.</a:t>
+              <a:t>The model is calibrated, and only high-confidence approvals clear. Everything else goes to a person. The fix for LLM overconfidence (Tian et al., 2025).</a:t>
             </a:r>
             <a:endParaRPr lang="en-US" sz="1250" dirty="0"/>
           </a:p>
@@ -9763,18 +9564,80 @@
       </p:sp>
       <p:sp>
         <p:nvSpPr>
-          <p:cNvPr id="15" name="Shape 13"/>
+          <p:cNvPr id="17" name="Shape 15"/>
+          <p:cNvSpPr/>
+          <p:nvPr/>
+        </p:nvSpPr>
+        <p:spPr>
+          <a:xfrm>
+            <a:off x="4553712" y="4608576"/>
+            <a:ext cx="3063240" cy="0"/>
+          </a:xfrm>
+          <a:prstGeom prst="line">
+            <a:avLst/>
+          </a:prstGeom>
+          <a:noFill/>
+          <a:ln w="12700">
+            <a:solidFill>
+              <a:srgbClr val="E2E8F0"/>
+            </a:solidFill>
+            <a:prstDash val="solid"/>
+          </a:ln>
+        </p:spPr>
+      </p:sp>
+      <p:sp>
+        <p:nvSpPr>
+          <p:cNvPr id="18" name="Text 16"/>
+          <p:cNvSpPr/>
+          <p:nvPr/>
+        </p:nvSpPr>
+        <p:spPr>
+          <a:xfrm>
+            <a:off x="4553712" y="4700016"/>
+            <a:ext cx="3108960" cy="457200"/>
+          </a:xfrm>
+          <a:prstGeom prst="rect">
+            <a:avLst/>
+          </a:prstGeom>
+          <a:noFill/>
+          <a:ln/>
+        </p:spPr>
+        <p:txBody>
+          <a:bodyPr wrap="square" lIns="0" tIns="0" rIns="0" bIns="0" rtlCol="0" anchor="ctr"/>
+          <a:lstStyle/>
+          <a:p>
+            <a:pPr indent="0" marL="0">
+              <a:buNone/>
+            </a:pPr>
+            <a:r>
+              <a:rPr lang="en-US" sz="1150" i="1" dirty="0">
+                <a:solidFill>
+                  <a:srgbClr val="0B5E5D"/>
+                </a:solidFill>
+                <a:latin typeface="Calibri" pitchFamily="34" charset="0"/>
+                <a:ea typeface="Calibri" pitchFamily="34" charset="-122"/>
+                <a:cs typeface="Calibri" pitchFamily="34" charset="-120"/>
+              </a:rPr>
+              <a:t>In the demo: CL-010 passed the rules but routed on confidence.</a:t>
+            </a:r>
+            <a:endParaRPr lang="en-US" sz="1150" dirty="0"/>
+          </a:p>
+        </p:txBody>
+      </p:sp>
+      <p:sp>
+        <p:nvSpPr>
+          <p:cNvPr id="19" name="Shape 17"/>
           <p:cNvSpPr/>
           <p:nvPr/>
         </p:nvSpPr>
         <p:spPr>
           <a:xfrm>
             <a:off x="8101584" y="1783080"/>
-            <a:ext cx="3611880" cy="2697480"/>
+            <a:ext cx="3611880" cy="3429000"/>
           </a:xfrm>
           <a:prstGeom prst="roundRect">
             <a:avLst>
-              <a:gd name="adj" fmla="val 2712"/>
+              <a:gd name="adj" fmla="val 2133"/>
             </a:avLst>
           </a:prstGeom>
           <a:solidFill>
@@ -9792,7 +9655,7 @@
       </p:sp>
       <p:sp>
         <p:nvSpPr>
-          <p:cNvPr id="16" name="Shape 14"/>
+          <p:cNvPr id="20" name="Shape 18"/>
           <p:cNvSpPr/>
           <p:nvPr/>
         </p:nvSpPr>
@@ -9812,7 +9675,7 @@
       </p:sp>
       <p:sp>
         <p:nvSpPr>
-          <p:cNvPr id="17" name="Text 15"/>
+          <p:cNvPr id="21" name="Text 19"/>
           <p:cNvSpPr/>
           <p:nvPr/>
         </p:nvSpPr>
@@ -9851,7 +9714,7 @@
       </p:sp>
       <p:sp>
         <p:nvSpPr>
-          <p:cNvPr id="18" name="Text 16"/>
+          <p:cNvPr id="22" name="Text 20"/>
           <p:cNvSpPr/>
           <p:nvPr/>
         </p:nvSpPr>
@@ -9890,14 +9753,14 @@
       </p:sp>
       <p:sp>
         <p:nvSpPr>
-          <p:cNvPr id="19" name="Text 17"/>
+          <p:cNvPr id="23" name="Text 21"/>
           <p:cNvSpPr/>
           <p:nvPr/>
         </p:nvSpPr>
         <p:spPr>
           <a:xfrm>
             <a:off x="8375904" y="3310128"/>
-            <a:ext cx="3108960" cy="1097280"/>
+            <a:ext cx="3108960" cy="1234440"/>
           </a:xfrm>
           <a:prstGeom prst="rect">
             <a:avLst/>
@@ -9921,7 +9784,7 @@
                 <a:ea typeface="Calibri" pitchFamily="34" charset="-122"/>
                 <a:cs typeface="Calibri" pitchFamily="34" charset="-120"/>
               </a:rPr>
-              <a:t>amount_anomaly is an independent z-score check that runs next to the LLM. The verdict never rests on the model by itself, because a second, classical signal stands behind it.</a:t>
+              <a:t>An independent z-score check runs alongside the model, so no verdict ever rests on the language model alone.</a:t>
             </a:r>
             <a:endParaRPr lang="en-US" sz="1250" dirty="0"/>
           </a:p>
@@ -9929,288 +9792,108 @@
       </p:sp>
       <p:sp>
         <p:nvSpPr>
-          <p:cNvPr id="20" name="Shape 18"/>
-          <p:cNvSpPr/>
-          <p:nvPr/>
-        </p:nvSpPr>
-        <p:spPr>
-          <a:xfrm>
-            <a:off x="457200" y="4663440"/>
-            <a:ext cx="7040880" cy="1691640"/>
-          </a:xfrm>
-          <a:prstGeom prst="roundRect">
-            <a:avLst>
-              <a:gd name="adj" fmla="val 4324"/>
-            </a:avLst>
-          </a:prstGeom>
-          <a:solidFill>
-            <a:srgbClr val="FFFFFF"/>
-          </a:solidFill>
-          <a:ln/>
-          <a:effectLst>
-            <a:outerShdw sx="100000" sy="100000" kx="0" ky="0" algn="bl" rotWithShape="0" blurRad="88900" dist="38100" dir="5400000">
-              <a:srgbClr val="9AA7B4">
-                <a:alpha val="22000"/>
-              </a:srgbClr>
-            </a:outerShdw>
-          </a:effectLst>
-        </p:spPr>
-      </p:sp>
-      <p:sp>
-        <p:nvSpPr>
-          <p:cNvPr id="21" name="Text 19"/>
-          <p:cNvSpPr/>
-          <p:nvPr/>
-        </p:nvSpPr>
-        <p:spPr>
-          <a:xfrm>
-            <a:off x="685800" y="4773168"/>
-            <a:ext cx="6583680" cy="292608"/>
-          </a:xfrm>
-          <a:prstGeom prst="rect">
-            <a:avLst/>
-          </a:prstGeom>
-          <a:noFill/>
-          <a:ln/>
-        </p:spPr>
-        <p:txBody>
-          <a:bodyPr wrap="square" lIns="0" tIns="0" rIns="0" bIns="0" rtlCol="0" anchor="ctr"/>
-          <a:lstStyle/>
-          <a:p>
-            <a:pPr indent="0" marL="0">
-              <a:buNone/>
-            </a:pPr>
-            <a:r>
-              <a:rPr lang="en-US" sz="1200" b="1" dirty="0">
-                <a:solidFill>
-                  <a:srgbClr val="1B2A4A"/>
-                </a:solidFill>
-                <a:latin typeface="Calibri" pitchFamily="34" charset="0"/>
-                <a:ea typeface="Calibri" pitchFamily="34" charset="-122"/>
-                <a:cs typeface="Calibri" pitchFamily="34" charset="-120"/>
-              </a:rPr>
-              <a:t>Pillar ③ in numbers:  CL-007, CPT 27447 (n=24)</a:t>
-            </a:r>
-            <a:endParaRPr lang="en-US" sz="1200" dirty="0"/>
-          </a:p>
-        </p:txBody>
-      </p:sp>
-      <p:graphicFrame>
-        <p:nvGraphicFramePr>
-          <p:cNvPr id="22" name="Chart 0" descr=""/>
-          <p:cNvGraphicFramePr/>
-          <p:nvPr/>
-        </p:nvGraphicFramePr>
-        <p:xfrm>
-          <a:off x="640080" y="5074920"/>
-          <a:ext cx="4297680" cy="1170432"/>
-        </p:xfrm>
-        <a:graphic xmlns:a="http://schemas.openxmlformats.org/drawingml/2006/main">
-          <a:graphicData uri="http://schemas.openxmlformats.org/drawingml/2006/chart">
-            <c:chart xmlns:c="http://schemas.openxmlformats.org/drawingml/2006/chart" r:id="rId1"/>
-          </a:graphicData>
-        </a:graphic>
-      </p:graphicFrame>
-      <p:sp>
-        <p:nvSpPr>
-          <p:cNvPr id="23" name="Text 20"/>
-          <p:cNvSpPr/>
-          <p:nvPr/>
-        </p:nvSpPr>
-        <p:spPr>
-          <a:xfrm>
-            <a:off x="5074920" y="5138928"/>
-            <a:ext cx="2331720" cy="1097280"/>
-          </a:xfrm>
-          <a:prstGeom prst="rect">
-            <a:avLst/>
-          </a:prstGeom>
-          <a:noFill/>
-          <a:ln/>
-        </p:spPr>
-        <p:txBody>
-          <a:bodyPr wrap="square" lIns="0" tIns="0" rIns="0" bIns="0" rtlCol="0" anchor="ctr"/>
-          <a:lstStyle/>
-          <a:p>
-            <a:pPr indent="0" marL="0">
-              <a:buNone/>
-            </a:pPr>
-            <a:r>
-              <a:rPr lang="en-US" sz="1250" b="1" dirty="0">
-                <a:solidFill>
-                  <a:srgbClr val="C0392B"/>
-                </a:solidFill>
-                <a:latin typeface="Calibri" pitchFamily="34" charset="0"/>
-                <a:ea typeface="Calibri" pitchFamily="34" charset="-122"/>
-                <a:cs typeface="Calibri" pitchFamily="34" charset="-120"/>
-              </a:rPr>
-              <a:t>This claim:  $48,000</a:t>
-            </a:r>
-            <a:endParaRPr lang="en-US" sz="1250" dirty="0"/>
-          </a:p>
-          <a:p>
-            <a:pPr indent="0" marL="0">
-              <a:buNone/>
-            </a:pPr>
-            <a:r>
-              <a:rPr lang="en-US" sz="1250" dirty="0">
-                <a:solidFill>
-                  <a:srgbClr val="334155"/>
-                </a:solidFill>
-                <a:latin typeface="Calibri" pitchFamily="34" charset="0"/>
-                <a:ea typeface="Calibri" pitchFamily="34" charset="-122"/>
-                <a:cs typeface="Calibri" pitchFamily="34" charset="-120"/>
-              </a:rPr>
-              <a:t>History mean $31,918</a:t>
-            </a:r>
-            <a:endParaRPr lang="en-US" sz="1250" dirty="0"/>
-          </a:p>
-          <a:p>
-            <a:pPr indent="0" marL="0">
-              <a:buNone/>
-            </a:pPr>
-            <a:r>
-              <a:rPr lang="en-US" sz="1250" b="1" dirty="0">
-                <a:solidFill>
-                  <a:srgbClr val="1E293B"/>
-                </a:solidFill>
-                <a:latin typeface="Calibri" pitchFamily="34" charset="0"/>
-                <a:ea typeface="Calibri" pitchFamily="34" charset="-122"/>
-                <a:cs typeface="Calibri" pitchFamily="34" charset="-120"/>
-              </a:rPr>
-              <a:t>z = 5.82  (5.8σ outlier)</a:t>
-            </a:r>
-            <a:endParaRPr lang="en-US" sz="1250" dirty="0"/>
-          </a:p>
-          <a:p>
-            <a:pPr indent="0" marL="0">
-              <a:buNone/>
-            </a:pPr>
-            <a:r>
-              <a:rPr lang="en-US" sz="1050" dirty="0">
-                <a:solidFill>
-                  <a:srgbClr val="64748B"/>
-                </a:solidFill>
-                <a:latin typeface="Calibri" pitchFamily="34" charset="0"/>
-                <a:ea typeface="Calibri" pitchFamily="34" charset="-122"/>
-                <a:cs typeface="Calibri" pitchFamily="34" charset="-120"/>
-              </a:rPr>
-              <a:t>Fires even though the hard $ cap passed.</a:t>
-            </a:r>
-            <a:endParaRPr lang="en-US" sz="1250" dirty="0"/>
-          </a:p>
-        </p:txBody>
-      </p:sp>
-      <p:sp>
-        <p:nvSpPr>
-          <p:cNvPr id="24" name="Shape 21"/>
-          <p:cNvSpPr/>
-          <p:nvPr/>
-        </p:nvSpPr>
-        <p:spPr>
-          <a:xfrm>
-            <a:off x="7680960" y="4663440"/>
-            <a:ext cx="4069080" cy="1691640"/>
-          </a:xfrm>
-          <a:prstGeom prst="roundRect">
-            <a:avLst>
-              <a:gd name="adj" fmla="val 4324"/>
-            </a:avLst>
-          </a:prstGeom>
-          <a:solidFill>
-            <a:srgbClr val="1B2A4A"/>
-          </a:solidFill>
-          <a:ln/>
-          <a:effectLst>
-            <a:outerShdw sx="100000" sy="100000" kx="0" ky="0" algn="bl" rotWithShape="0" blurRad="88900" dist="38100" dir="5400000">
-              <a:srgbClr val="9AA7B4">
-                <a:alpha val="22000"/>
-              </a:srgbClr>
-            </a:outerShdw>
-          </a:effectLst>
-        </p:spPr>
-      </p:sp>
-      <p:sp>
-        <p:nvSpPr>
-          <p:cNvPr id="25" name="Text 22"/>
-          <p:cNvSpPr/>
-          <p:nvPr/>
-        </p:nvSpPr>
-        <p:spPr>
-          <a:xfrm>
-            <a:off x="7909560" y="4791456"/>
-            <a:ext cx="3657600" cy="310896"/>
-          </a:xfrm>
-          <a:prstGeom prst="rect">
-            <a:avLst/>
-          </a:prstGeom>
-          <a:noFill/>
-          <a:ln/>
-        </p:spPr>
-        <p:txBody>
-          <a:bodyPr wrap="square" lIns="0" tIns="0" rIns="0" bIns="0" rtlCol="0" anchor="ctr"/>
-          <a:lstStyle/>
-          <a:p>
-            <a:pPr indent="0" marL="0">
-              <a:buNone/>
-            </a:pPr>
-            <a:r>
-              <a:rPr lang="en-US" sz="1500" b="1" dirty="0">
-                <a:solidFill>
-                  <a:srgbClr val="5EEAD4"/>
+          <p:cNvPr id="24" name="Shape 22"/>
+          <p:cNvSpPr/>
+          <p:nvPr/>
+        </p:nvSpPr>
+        <p:spPr>
+          <a:xfrm>
+            <a:off x="8375904" y="4608576"/>
+            <a:ext cx="3063240" cy="0"/>
+          </a:xfrm>
+          <a:prstGeom prst="line">
+            <a:avLst/>
+          </a:prstGeom>
+          <a:noFill/>
+          <a:ln w="12700">
+            <a:solidFill>
+              <a:srgbClr val="E2E8F0"/>
+            </a:solidFill>
+            <a:prstDash val="solid"/>
+          </a:ln>
+        </p:spPr>
+      </p:sp>
+      <p:sp>
+        <p:nvSpPr>
+          <p:cNvPr id="25" name="Text 23"/>
+          <p:cNvSpPr/>
+          <p:nvPr/>
+        </p:nvSpPr>
+        <p:spPr>
+          <a:xfrm>
+            <a:off x="8375904" y="4700016"/>
+            <a:ext cx="3108960" cy="457200"/>
+          </a:xfrm>
+          <a:prstGeom prst="rect">
+            <a:avLst/>
+          </a:prstGeom>
+          <a:noFill/>
+          <a:ln/>
+        </p:spPr>
+        <p:txBody>
+          <a:bodyPr wrap="square" lIns="0" tIns="0" rIns="0" bIns="0" rtlCol="0" anchor="ctr"/>
+          <a:lstStyle/>
+          <a:p>
+            <a:pPr indent="0" marL="0">
+              <a:buNone/>
+            </a:pPr>
+            <a:r>
+              <a:rPr lang="en-US" sz="1150" i="1" dirty="0">
+                <a:solidFill>
+                  <a:srgbClr val="0B5E5D"/>
+                </a:solidFill>
+                <a:latin typeface="Calibri" pitchFamily="34" charset="0"/>
+                <a:ea typeface="Calibri" pitchFamily="34" charset="-122"/>
+                <a:cs typeface="Calibri" pitchFamily="34" charset="-120"/>
+              </a:rPr>
+              <a:t>In the demo: CL-007 passed every rule; the anomaly caught it.</a:t>
+            </a:r>
+            <a:endParaRPr lang="en-US" sz="1150" dirty="0"/>
+          </a:p>
+        </p:txBody>
+      </p:sp>
+      <p:sp>
+        <p:nvSpPr>
+          <p:cNvPr id="26" name="Text 24"/>
+          <p:cNvSpPr/>
+          <p:nvPr/>
+        </p:nvSpPr>
+        <p:spPr>
+          <a:xfrm>
+            <a:off x="457200" y="5532120"/>
+            <a:ext cx="11292840" cy="457200"/>
+          </a:xfrm>
+          <a:prstGeom prst="rect">
+            <a:avLst/>
+          </a:prstGeom>
+          <a:noFill/>
+          <a:ln/>
+        </p:spPr>
+        <p:txBody>
+          <a:bodyPr wrap="square" lIns="0" tIns="0" rIns="0" bIns="0" rtlCol="0" anchor="ctr"/>
+          <a:lstStyle/>
+          <a:p>
+            <a:pPr algn="ctr" indent="0" marL="0">
+              <a:buNone/>
+            </a:pPr>
+            <a:r>
+              <a:rPr lang="en-US" sz="1600" b="1" i="1" dirty="0">
+                <a:solidFill>
+                  <a:srgbClr val="0B5E5D"/>
                 </a:solidFill>
                 <a:latin typeface="Cambria" pitchFamily="34" charset="0"/>
                 <a:ea typeface="Cambria" pitchFamily="34" charset="-122"/>
                 <a:cs typeface="Cambria" pitchFamily="34" charset="-120"/>
               </a:rPr>
-              <a:t>RAG honesty</a:t>
-            </a:r>
-            <a:endParaRPr lang="en-US" sz="1500" dirty="0"/>
-          </a:p>
-        </p:txBody>
-      </p:sp>
-      <p:sp>
-        <p:nvSpPr>
-          <p:cNvPr id="26" name="Text 23"/>
-          <p:cNvSpPr/>
-          <p:nvPr/>
-        </p:nvSpPr>
-        <p:spPr>
-          <a:xfrm>
-            <a:off x="7909560" y="5138928"/>
-            <a:ext cx="3611880" cy="1143000"/>
-          </a:xfrm>
-          <a:prstGeom prst="rect">
-            <a:avLst/>
-          </a:prstGeom>
-          <a:noFill/>
-          <a:ln/>
-        </p:spPr>
-        <p:txBody>
-          <a:bodyPr wrap="square" lIns="0" tIns="0" rIns="0" bIns="0" rtlCol="0" anchor="ctr"/>
-          <a:lstStyle/>
-          <a:p>
-            <a:pPr indent="0" marL="0">
-              <a:buNone/>
-            </a:pPr>
-            <a:r>
-              <a:rPr lang="en-US" sz="1250" dirty="0">
-                <a:solidFill>
-                  <a:srgbClr val="DCE6F0"/>
-                </a:solidFill>
-                <a:latin typeface="Calibri" pitchFamily="34" charset="0"/>
-                <a:ea typeface="Calibri" pitchFamily="34" charset="-122"/>
-                <a:cs typeface="Calibri" pitchFamily="34" charset="-120"/>
-              </a:rPr>
-              <a:t>The POC skips real RAG to stay simple. lookup_policy plays the part of a production retrieval step: same agent loop, simpler backend. The demo is upfront about that and never fakes retrieval it isn't doing.</a:t>
-            </a:r>
-            <a:endParaRPr lang="en-US" sz="1250" dirty="0"/>
-          </a:p>
-        </p:txBody>
-      </p:sp>
-      <p:sp>
-        <p:nvSpPr>
-          <p:cNvPr id="27" name="Text 24"/>
+              <a:t>These aren't claims about the system. They're things you just watched it do.</a:t>
+            </a:r>
+            <a:endParaRPr lang="en-US" sz="1600" dirty="0"/>
+          </a:p>
+        </p:txBody>
+      </p:sp>
+      <p:sp>
+        <p:nvSpPr>
+          <p:cNvPr id="27" name="Text 25"/>
           <p:cNvSpPr/>
           <p:nvPr/>
         </p:nvSpPr>
@@ -10249,7 +9932,7 @@
       </p:sp>
       <p:sp>
         <p:nvSpPr>
-          <p:cNvPr id="28" name="Text 25"/>
+          <p:cNvPr id="28" name="Text 26"/>
           <p:cNvSpPr/>
           <p:nvPr/>
         </p:nvSpPr>

</xml_diff>